<commit_message>
case study slides refining
</commit_message>
<xml_diff>
--- a/case_study_v2.pptx
+++ b/case_study_v2.pptx
@@ -3603,7 +3603,7 @@
         <p:spPr>
           <a:xfrm>
             <a:off x="228600" y="310896"/>
-            <a:ext cx="59436" cy="502920"/>
+            <a:ext cx="59436" cy="731520"/>
           </a:xfrm>
           <a:prstGeom prst="rect">
             <a:avLst/>
@@ -3645,8 +3645,8 @@
         </p:nvSpPr>
         <p:spPr>
           <a:xfrm>
-            <a:off x="402336" y="274320"/>
-            <a:ext cx="8686800" cy="548640"/>
+            <a:off x="402336" y="310896"/>
+            <a:ext cx="11384280" cy="731520"/>
           </a:xfrm>
           <a:prstGeom prst="rect">
             <a:avLst/>
@@ -3663,9 +3663,18 @@
             <a:r>
               <a:rPr sz="2400" b="1">
                 <a:solidFill>
+                  <a:srgbClr val="C02026"/>
+                </a:solidFill>
+                <a:latin typeface="Oswald"/>
+              </a:rPr>
+              <a:t>CASE STUDY: </a:t>
+            </a:r>
+            <a:r>
+              <a:rPr sz="2400" b="1">
+                <a:solidFill>
                   <a:srgbClr val="111110"/>
                 </a:solidFill>
-                <a:latin typeface="Calibri"/>
+                <a:latin typeface="Oswald"/>
               </a:rPr>
               <a:t>{{TITLE}}</a:t>
             </a:r>
@@ -3680,8 +3689,8 @@
         </p:nvSpPr>
         <p:spPr>
           <a:xfrm>
-            <a:off x="402336" y="676656"/>
-            <a:ext cx="11430000" cy="310896"/>
+            <a:off x="402336" y="804672"/>
+            <a:ext cx="11384280" cy="274320"/>
           </a:xfrm>
           <a:prstGeom prst="rect">
             <a:avLst/>
@@ -3700,7 +3709,7 @@
                 <a:solidFill>
                   <a:srgbClr val="3A8B82"/>
                 </a:solidFill>
-                <a:latin typeface="Calibri"/>
+                <a:latin typeface="Oswald"/>
               </a:rPr>
               <a:t>CLIENT: {{CLIENT}}  |  DOMAIN: {{DOMAIN}}</a:t>
             </a:r>
@@ -3823,7 +3832,7 @@
                 <a:solidFill>
                   <a:srgbClr val="111110"/>
                 </a:solidFill>
-                <a:latin typeface="Calibri"/>
+                <a:latin typeface="Helvetica"/>
               </a:rPr>
               <a:t>The Challenge</a:t>
             </a:r>
@@ -3858,7 +3867,7 @@
                 <a:solidFill>
                   <a:srgbClr val="3E3E3E"/>
                 </a:solidFill>
-                <a:latin typeface="Calibri"/>
+                <a:latin typeface="Helvetica"/>
               </a:rPr>
               <a:t>{{CHALLENGE}}</a:t>
             </a:r>
@@ -3981,7 +3990,7 @@
                 <a:solidFill>
                   <a:srgbClr val="111110"/>
                 </a:solidFill>
-                <a:latin typeface="Calibri"/>
+                <a:latin typeface="Helvetica"/>
               </a:rPr>
               <a:t>The Solution</a:t>
             </a:r>
@@ -4016,7 +4025,7 @@
                 <a:solidFill>
                   <a:srgbClr val="3E3E3E"/>
                 </a:solidFill>
-                <a:latin typeface="Calibri"/>
+                <a:latin typeface="Helvetica"/>
               </a:rPr>
               <a:t>{{SOLUTION}}</a:t>
             </a:r>
@@ -4051,7 +4060,7 @@
                 <a:solidFill>
                   <a:srgbClr val="3A8B82"/>
                 </a:solidFill>
-                <a:latin typeface="Calibri"/>
+                <a:latin typeface="Helvetica"/>
               </a:rPr>
               <a:t>Key Capabilities Developed</a:t>
             </a:r>
@@ -4131,7 +4140,7 @@
                 <a:solidFill>
                   <a:srgbClr val="111110"/>
                 </a:solidFill>
-                <a:latin typeface="Calibri"/>
+                <a:latin typeface="Helvetica"/>
               </a:rPr>
               <a:t>{{CAP_1_TITLE}}</a:t>
             </a:r>
@@ -4166,7 +4175,7 @@
                 <a:solidFill>
                   <a:srgbClr val="3E3E3E"/>
                 </a:solidFill>
-                <a:latin typeface="Calibri"/>
+                <a:latin typeface="Helvetica"/>
               </a:rPr>
               <a:t>{{CAP_1_BODY}}</a:t>
             </a:r>
@@ -4246,7 +4255,7 @@
                 <a:solidFill>
                   <a:srgbClr val="111110"/>
                 </a:solidFill>
-                <a:latin typeface="Calibri"/>
+                <a:latin typeface="Helvetica"/>
               </a:rPr>
               <a:t>{{CAP_2_TITLE}}</a:t>
             </a:r>
@@ -4281,7 +4290,7 @@
                 <a:solidFill>
                   <a:srgbClr val="3E3E3E"/>
                 </a:solidFill>
-                <a:latin typeface="Calibri"/>
+                <a:latin typeface="Helvetica"/>
               </a:rPr>
               <a:t>{{CAP_2_BODY}}</a:t>
             </a:r>
@@ -4361,7 +4370,7 @@
                 <a:solidFill>
                   <a:srgbClr val="111110"/>
                 </a:solidFill>
-                <a:latin typeface="Calibri"/>
+                <a:latin typeface="Helvetica"/>
               </a:rPr>
               <a:t>{{CAP_3_TITLE}}</a:t>
             </a:r>
@@ -4396,7 +4405,7 @@
                 <a:solidFill>
                   <a:srgbClr val="3E3E3E"/>
                 </a:solidFill>
-                <a:latin typeface="Calibri"/>
+                <a:latin typeface="Helvetica"/>
               </a:rPr>
               <a:t>{{CAP_3_BODY}}</a:t>
             </a:r>
@@ -4476,7 +4485,7 @@
                 <a:solidFill>
                   <a:srgbClr val="111110"/>
                 </a:solidFill>
-                <a:latin typeface="Calibri"/>
+                <a:latin typeface="Helvetica"/>
               </a:rPr>
               <a:t>{{CAP_4_TITLE}}</a:t>
             </a:r>
@@ -4511,7 +4520,7 @@
                 <a:solidFill>
                   <a:srgbClr val="3E3E3E"/>
                 </a:solidFill>
-                <a:latin typeface="Calibri"/>
+                <a:latin typeface="Helvetica"/>
               </a:rPr>
               <a:t>{{CAP_4_BODY}}</a:t>
             </a:r>
@@ -4591,7 +4600,7 @@
                 <a:solidFill>
                   <a:srgbClr val="111110"/>
                 </a:solidFill>
-                <a:latin typeface="Calibri"/>
+                <a:latin typeface="Helvetica"/>
               </a:rPr>
               <a:t>{{CAP_5_TITLE}}</a:t>
             </a:r>
@@ -4626,7 +4635,7 @@
                 <a:solidFill>
                   <a:srgbClr val="3E3E3E"/>
                 </a:solidFill>
-                <a:latin typeface="Calibri"/>
+                <a:latin typeface="Helvetica"/>
               </a:rPr>
               <a:t>{{CAP_5_BODY}}</a:t>
             </a:r>
@@ -4706,7 +4715,7 @@
                 <a:solidFill>
                   <a:srgbClr val="111110"/>
                 </a:solidFill>
-                <a:latin typeface="Calibri"/>
+                <a:latin typeface="Helvetica"/>
               </a:rPr>
               <a:t>{{CAP_6_TITLE}}</a:t>
             </a:r>
@@ -4741,7 +4750,7 @@
                 <a:solidFill>
                   <a:srgbClr val="3E3E3E"/>
                 </a:solidFill>
-                <a:latin typeface="Calibri"/>
+                <a:latin typeface="Helvetica"/>
               </a:rPr>
               <a:t>{{CAP_6_BODY}}</a:t>
             </a:r>
@@ -4756,8 +4765,8 @@
         </p:nvSpPr>
         <p:spPr>
           <a:xfrm>
-            <a:off x="0" y="5486400"/>
-            <a:ext cx="12188952" cy="1371600"/>
+            <a:off x="0" y="5669280"/>
+            <a:ext cx="12188952" cy="1188719"/>
           </a:xfrm>
           <a:prstGeom prst="rect">
             <a:avLst/>
@@ -4799,8 +4808,8 @@
         </p:nvSpPr>
         <p:spPr>
           <a:xfrm>
-            <a:off x="182880" y="5614416"/>
-            <a:ext cx="3697223" cy="603504"/>
+            <a:off x="182880" y="5815584"/>
+            <a:ext cx="3697223" cy="475488"/>
           </a:xfrm>
           <a:prstGeom prst="rect">
             <a:avLst/>
@@ -4815,11 +4824,11 @@
           <a:p>
             <a:pPr algn="ctr"/>
             <a:r>
-              <a:rPr sz="3400" b="1">
+              <a:rPr sz="2500" b="1">
                 <a:solidFill>
                   <a:srgbClr val="FFFFFF"/>
                 </a:solidFill>
-                <a:latin typeface="Calibri"/>
+                <a:latin typeface="Helvetica"/>
               </a:rPr>
               <a:t>{{RESULT_1_PCT}}</a:t>
             </a:r>
@@ -4835,7 +4844,7 @@
         <p:spPr>
           <a:xfrm>
             <a:off x="137160" y="6272784"/>
-            <a:ext cx="3788664" cy="502920"/>
+            <a:ext cx="3788664" cy="548640"/>
           </a:xfrm>
           <a:prstGeom prst="rect">
             <a:avLst/>
@@ -4850,11 +4859,11 @@
           <a:p>
             <a:pPr algn="ctr"/>
             <a:r>
-              <a:rPr sz="900" b="0">
+              <a:rPr sz="1200" b="0">
                 <a:solidFill>
                   <a:srgbClr val="FFFFFF"/>
                 </a:solidFill>
-                <a:latin typeface="Calibri"/>
+                <a:latin typeface="Helvetica"/>
               </a:rPr>
               <a:t>{{RESULT_1_TEXT}}</a:t>
             </a:r>
@@ -4869,8 +4878,8 @@
         </p:nvSpPr>
         <p:spPr>
           <a:xfrm>
-            <a:off x="4245864" y="5614416"/>
-            <a:ext cx="3697223" cy="603504"/>
+            <a:off x="4245864" y="5815584"/>
+            <a:ext cx="3697223" cy="475488"/>
           </a:xfrm>
           <a:prstGeom prst="rect">
             <a:avLst/>
@@ -4885,11 +4894,11 @@
           <a:p>
             <a:pPr algn="ctr"/>
             <a:r>
-              <a:rPr sz="3400" b="1">
+              <a:rPr sz="2500" b="1">
                 <a:solidFill>
                   <a:srgbClr val="FFFFFF"/>
                 </a:solidFill>
-                <a:latin typeface="Calibri"/>
+                <a:latin typeface="Helvetica"/>
               </a:rPr>
               <a:t>{{RESULT_2_PCT}}</a:t>
             </a:r>
@@ -4905,7 +4914,7 @@
         <p:spPr>
           <a:xfrm>
             <a:off x="4200144" y="6272784"/>
-            <a:ext cx="3788664" cy="502920"/>
+            <a:ext cx="3788664" cy="548640"/>
           </a:xfrm>
           <a:prstGeom prst="rect">
             <a:avLst/>
@@ -4920,11 +4929,11 @@
           <a:p>
             <a:pPr algn="ctr"/>
             <a:r>
-              <a:rPr sz="900" b="0">
+              <a:rPr sz="1200" b="0">
                 <a:solidFill>
                   <a:srgbClr val="FFFFFF"/>
                 </a:solidFill>
-                <a:latin typeface="Calibri"/>
+                <a:latin typeface="Helvetica"/>
               </a:rPr>
               <a:t>{{RESULT_2_TEXT}}</a:t>
             </a:r>
@@ -4939,8 +4948,8 @@
         </p:nvSpPr>
         <p:spPr>
           <a:xfrm>
-            <a:off x="8308847" y="5614416"/>
-            <a:ext cx="3697223" cy="603504"/>
+            <a:off x="8308847" y="5815584"/>
+            <a:ext cx="3697223" cy="475488"/>
           </a:xfrm>
           <a:prstGeom prst="rect">
             <a:avLst/>
@@ -4955,11 +4964,11 @@
           <a:p>
             <a:pPr algn="ctr"/>
             <a:r>
-              <a:rPr sz="3400" b="1">
+              <a:rPr sz="2500" b="1">
                 <a:solidFill>
                   <a:srgbClr val="FFFFFF"/>
                 </a:solidFill>
-                <a:latin typeface="Calibri"/>
+                <a:latin typeface="Helvetica"/>
               </a:rPr>
               <a:t>{{RESULT_3_PCT}}</a:t>
             </a:r>
@@ -4975,7 +4984,7 @@
         <p:spPr>
           <a:xfrm>
             <a:off x="8263128" y="6272784"/>
-            <a:ext cx="3788664" cy="502920"/>
+            <a:ext cx="3788664" cy="548640"/>
           </a:xfrm>
           <a:prstGeom prst="rect">
             <a:avLst/>
@@ -4990,11 +4999,11 @@
           <a:p>
             <a:pPr algn="ctr"/>
             <a:r>
-              <a:rPr sz="900" b="0">
+              <a:rPr sz="1200" b="0">
                 <a:solidFill>
                   <a:srgbClr val="FFFFFF"/>
                 </a:solidFill>
-                <a:latin typeface="Calibri"/>
+                <a:latin typeface="Helvetica"/>
               </a:rPr>
               <a:t>{{RESULT_3_TEXT}}</a:t>
             </a:r>

</xml_diff>